<commit_message>
fix(evidencias): la ppt no cita la carpeta vieja ni rutas locales
La validación cruzada del #183 (Lucca) encontró dos restos que el
`git grep` no ve porque están dentro del binario:
- las notas de la lámina 10 decían «Evidencias de sistema/Aplicacion»;
- el layout 3 tenía el texto alternativo del logo con la ruta
  /home/edgar/… (la comprobación anterior solo miraba ppt/slides/).

Cómo se comprobó: recorrido de todas las partes .xml y .rels del pptx,
0 «/home/» y 0 «Aplicacion»; validate.py «All validations PASSED!»;
PowerPoint abre y exporta las 15 láminas.

Co-Authored-By: Claude Opus 5.5 <noreply@anthropic.com>
</commit_message>
<xml_diff>
--- a/Fase 2/Evidencias Proyecto/Presentación Proyecto.pptx
+++ b/Fase 2/Evidencias Proyecto/Presentación Proyecto.pptx
@@ -1005,7 +1005,7 @@
           <a:lstStyle/>
           <a:p>
             <a:r>
-              <a:t>Sugerido: presenta Lian. Las pantallas principales de la web. Panel, reglas y cola se capturaron contra el contrato simulado (Prism); el pedido en proceso es el sistema real con el modelo. Todo está en Fase 2/Evidencias Proyecto/Evidencias de sistema/Aplicacion.</a:t>
+              <a:t>Sugerido: presenta Lian. Las pantallas principales de la web. Panel, reglas y cola se capturaron contra el contrato simulado (Prism); el pedido en proceso es el sistema real con el modelo. Todo está en Fase 2/Evidencias Proyecto/Evidencias de sistema/Aplicación.</a:t>
             </a:r>
           </a:p>
         </p:txBody>
@@ -1952,7 +1952,7 @@
       </p:grpSpPr>
       <p:pic>
         <p:nvPicPr>
-          <p:cNvPr id="2" name="Image 0" descr="/home/edgar/personal/duoc/_generadores/presentacion_fase2_teddy/logo_duoc.jpg"/>
+          <p:cNvPr id="2" name="Image 0" descr="Logo de Duoc UC"/>
           <p:cNvPicPr>
             <a:picLocks noChangeAspect="1"/>
           </p:cNvPicPr>

</xml_diff>